<commit_message>
Workshop prep: tune snitch, document pre-provisioned EKS
- Set dynamic_snitch_badness_threshold=0.1 to prevent self-reinforcing
  hot replica at sub-ms latencies; note 2-AZ token allocator stall
- Rewrite workshop skill for externally-managed EKS (no eksctl
  create/delete, 9-node ring cap, MCP first-deploy crash-loop note)
- Update reference architecture deck
- Ignore .claude/worktrees/ scratch dir

Co-Authored-By: Claude Opus 4.7 (1M context) <noreply@anthropic.com>
</commit_message>
<xml_diff>
--- a/k8ssandra-reference-architecture.pptx
+++ b/k8ssandra-reference-architecture.pptx
@@ -13,8 +13,8 @@
     <p:sldId id="260" r:id="rId7"/>
     <p:sldId id="261" r:id="rId8"/>
     <p:sldId id="262" r:id="rId9"/>
-    <p:sldId id="264" r:id="rId14"/>
-    <p:sldId id="265" r:id="rId15"/>
+    <p:sldId id="264" r:id="rId10"/>
+    <p:sldId id="265" r:id="rId11"/>
   </p:sldIdLst>
   <p:sldSz cx="12192000" cy="6858000"/>
   <p:notesSz cx="6858000" cy="9144000"/>
@@ -3548,7 +3548,7 @@
             </a:pPr>
             <a:r>
               <a:rPr sz="1400"/>
-              <a:t xml:space="preserve">     -p='[{"op":"replace","path":"/spec/cassandra/datacenters/0/size","value":9}]'</a:t>
+              <a:t>     -p='[{"op":"replace","path":"/spec/cassandra/datacenters/0/size","value":9}]'</a:t>
             </a:r>
           </a:p>
         </p:txBody>
@@ -12892,7 +12892,7 @@
             </a:pPr>
             <a:r>
               <a:rPr sz="1100" dirty="0"/>
-              <a:t xml:space="preserve">Issuer / </a:t>
+              <a:t>Issuer / </a:t>
             </a:r>
             <a:r>
               <a:rPr sz="1100" dirty="0" err="1"/>
@@ -13587,7 +13587,7 @@
             </a:r>
             <a:r>
               <a:rPr sz="1100" dirty="0"/>
-              <a:t xml:space="preserve">, </a:t>
+              <a:t>, </a:t>
             </a:r>
             <a:r>
               <a:rPr sz="1100" dirty="0" err="1"/>

</xml_diff>